<commit_message>
Add future scope to the presentation
</commit_message>
<xml_diff>
--- a/deliverables/FinalityDesk-presentation.pptx
+++ b/deliverables/FinalityDesk-presentation.pptx
@@ -2,18 +2,19 @@
 <file path=ppt/presentation.xml><?xml version="1.0" encoding="utf-8"?>
 <p:presentation xmlns:p="http://schemas.openxmlformats.org/presentationml/2006/main">
   <p:sldMasterIdLst>
-    <p:sldMasterId xmlns:r="http://schemas.openxmlformats.org/officeDocument/2006/relationships" id="2147483648" r:id="R44d02b0bd2e4468b"/>
+    <p:sldMasterId xmlns:r="http://schemas.openxmlformats.org/officeDocument/2006/relationships" id="2147483648" r:id="R35ebecc9392b4700"/>
   </p:sldMasterIdLst>
   <p:notesMasterIdLst>
-    <p:notesMasterId xmlns:r="http://schemas.openxmlformats.org/officeDocument/2006/relationships" r:id="R8850383029a14ccf"/>
+    <p:notesMasterId xmlns:r="http://schemas.openxmlformats.org/officeDocument/2006/relationships" r:id="Rb78af327f1644cf7"/>
   </p:notesMasterIdLst>
   <p:sldIdLst>
-    <p:sldId xmlns:r="http://schemas.openxmlformats.org/officeDocument/2006/relationships" id="256" r:id="Rab4bbb0968a14529"/>
-    <p:sldId xmlns:r="http://schemas.openxmlformats.org/officeDocument/2006/relationships" id="257" r:id="Rc1872014c9ad4960"/>
-    <p:sldId xmlns:r="http://schemas.openxmlformats.org/officeDocument/2006/relationships" id="258" r:id="R30ed25c0b4f64c4b"/>
-    <p:sldId xmlns:r="http://schemas.openxmlformats.org/officeDocument/2006/relationships" id="259" r:id="Rb1bc1e01f2044d16"/>
-    <p:sldId xmlns:r="http://schemas.openxmlformats.org/officeDocument/2006/relationships" id="260" r:id="Raec4611c374c4ede"/>
-    <p:sldId xmlns:r="http://schemas.openxmlformats.org/officeDocument/2006/relationships" id="261" r:id="R35a6912308314d83"/>
+    <p:sldId xmlns:r="http://schemas.openxmlformats.org/officeDocument/2006/relationships" id="256" r:id="R782f348348e64899"/>
+    <p:sldId xmlns:r="http://schemas.openxmlformats.org/officeDocument/2006/relationships" id="257" r:id="R49cd3cdd0c0b4ac9"/>
+    <p:sldId xmlns:r="http://schemas.openxmlformats.org/officeDocument/2006/relationships" id="258" r:id="Rca89f997cf354339"/>
+    <p:sldId xmlns:r="http://schemas.openxmlformats.org/officeDocument/2006/relationships" id="259" r:id="R5ff388c834414acf"/>
+    <p:sldId xmlns:r="http://schemas.openxmlformats.org/officeDocument/2006/relationships" id="260" r:id="Rfcd0d2bca0b742fb"/>
+    <p:sldId xmlns:r="http://schemas.openxmlformats.org/officeDocument/2006/relationships" id="261" r:id="Re0b6173296d74476"/>
+    <p:sldId xmlns:r="http://schemas.openxmlformats.org/officeDocument/2006/relationships" id="262" r:id="R7b1f39493e2c4253"/>
   </p:sldIdLst>
   <p:sldSz cx="12192000" cy="6858000"/>
   <p:notesSz cx="6858000" cy="9144000"/>
@@ -827,6 +828,76 @@
 </p:notes>
 </file>
 
+<file path=ppt/notesSlides/notesSlide7.xml><?xml version="1.0" encoding="utf-8"?>
+<p:notes xmlns:p="http://schemas.openxmlformats.org/presentationml/2006/main">
+  <p:cSld>
+    <p:spTree>
+      <p:nvGrpSpPr>
+        <p:cNvPr id="1" name=""/>
+        <p:cNvGrpSpPr/>
+        <p:nvPr/>
+      </p:nvGrpSpPr>
+      <p:grpSpPr>
+        <a:xfrm xmlns:a="http://schemas.openxmlformats.org/drawingml/2006/main"/>
+      </p:grpSpPr>
+      <p:sp>
+        <p:nvSpPr>
+          <p:cNvPr id="2" name="Slide Image Placeholder 1"/>
+          <p:cNvSpPr>
+            <a:spLocks xmlns:a="http://schemas.openxmlformats.org/drawingml/2006/main" noGrp="1"/>
+          </p:cNvSpPr>
+          <p:nvPr>
+            <p:ph type="sldImg" idx="0"/>
+          </p:nvPr>
+        </p:nvSpPr>
+        <p:spPr/>
+      </p:sp>
+      <p:sp>
+        <p:nvSpPr>
+          <p:cNvPr id="3" name="Notes Placeholder 2"/>
+          <p:cNvSpPr>
+            <a:spLocks xmlns:a="http://schemas.openxmlformats.org/drawingml/2006/main" noGrp="1"/>
+          </p:cNvSpPr>
+          <p:nvPr>
+            <p:ph type="body" idx="1"/>
+          </p:nvPr>
+        </p:nvSpPr>
+        <p:spPr/>
+        <p:txBody>
+          <a:bodyPr xmlns:a="http://schemas.openxmlformats.org/drawingml/2006/main"/>
+          <a:lstStyle xmlns:a="http://schemas.openxmlformats.org/drawingml/2006/main"/>
+          <a:p xmlns:a="http://schemas.openxmlformats.org/drawingml/2006/main">
+            <a:r>
+              <a:t>Source: https://devpost.com/software/finalitydesk — What is next for FinalityDesk. The next step is independent-provider comparison and explicit invoice identifiers. These are not implemented in this prototype.</a:t>
+            </a:r>
+          </a:p>
+        </p:txBody>
+      </p:sp>
+      <p:sp>
+        <p:nvSpPr>
+          <p:cNvPr id="4" name="Slide Number Placeholder 3"/>
+          <p:cNvSpPr>
+            <a:spLocks xmlns:a="http://schemas.openxmlformats.org/drawingml/2006/main" noGrp="1"/>
+          </p:cNvSpPr>
+          <p:nvPr>
+            <p:ph type="sldNum" idx="5"/>
+          </p:nvPr>
+        </p:nvSpPr>
+        <p:spPr/>
+        <p:txBody>
+          <a:bodyPr xmlns:a="http://schemas.openxmlformats.org/drawingml/2006/main"/>
+          <a:lstStyle xmlns:a="http://schemas.openxmlformats.org/drawingml/2006/main"/>
+          <a:p xmlns:a="http://schemas.openxmlformats.org/drawingml/2006/main"/>
+        </p:txBody>
+      </p:sp>
+    </p:spTree>
+  </p:cSld>
+  <p:clrMapOvr>
+    <a:masterClrMapping xmlns:a="http://schemas.openxmlformats.org/drawingml/2006/main"/>
+  </p:clrMapOvr>
+</p:notes>
+</file>
+
 <file path=ppt/slideLayouts/slideLayout1.xml><?xml version="1.0" encoding="utf-8"?>
 <p:sldLayout xmlns:p="http://schemas.openxmlformats.org/presentationml/2006/main" type="title">
   <p:cSld name="Title Slide">
@@ -865,7 +936,7 @@
   </p:cSld>
   <p:clrMap bg1="lt1" tx1="dk1" bg2="lt2" tx2="dk2" accent1="accent1" accent2="accent2" accent3="accent3" accent4="accent4" accent5="accent5" accent6="accent6" hlink="hlink" folHlink="folHlink"/>
   <p:sldLayoutIdLst>
-    <p:sldLayoutId xmlns:r="http://schemas.openxmlformats.org/officeDocument/2006/relationships" id="2147483649" r:id="Rcc75e69959f54687"/>
+    <p:sldLayoutId xmlns:r="http://schemas.openxmlformats.org/officeDocument/2006/relationships" id="2147483649" r:id="R3cee14d9b8e442ab"/>
   </p:sldLayoutIdLst>
   <p:txStyles>
     <p:titleStyle>
@@ -1445,6 +1516,7 @@
           <a:lstStyle xmlns:a="http://schemas.openxmlformats.org/drawingml/2006/main"/>
           <a:p xmlns:a="http://schemas.openxmlformats.org/drawingml/2006/main">
             <a:pPr>
+              <a:buNone/>
               <a:defRPr sz="3600" b="1">
                 <a:solidFill>
                   <a:srgbClr val="171B19"/>
@@ -1502,6 +1574,7 @@
           <a:lstStyle xmlns:a="http://schemas.openxmlformats.org/drawingml/2006/main"/>
           <a:p xmlns:a="http://schemas.openxmlformats.org/drawingml/2006/main">
             <a:pPr>
+              <a:buNone/>
               <a:defRPr sz="4350" b="0">
                 <a:solidFill>
                   <a:srgbClr val="171B19"/>
@@ -1525,6 +1598,7 @@
           </a:p>
           <a:p xmlns:a="http://schemas.openxmlformats.org/drawingml/2006/main">
             <a:pPr>
+              <a:buNone/>
               <a:defRPr sz="4350" b="0">
                 <a:solidFill>
                   <a:srgbClr val="171B19"/>
@@ -1582,6 +1656,7 @@
           <a:lstStyle xmlns:a="http://schemas.openxmlformats.org/drawingml/2006/main"/>
           <a:p xmlns:a="http://schemas.openxmlformats.org/drawingml/2006/main">
             <a:pPr>
+              <a:buNone/>
               <a:defRPr sz="2100" b="0">
                 <a:solidFill>
                   <a:srgbClr val="171B19"/>
@@ -1668,6 +1743,7 @@
           <a:lstStyle xmlns:a="http://schemas.openxmlformats.org/drawingml/2006/main"/>
           <a:p xmlns:a="http://schemas.openxmlformats.org/drawingml/2006/main">
             <a:pPr>
+              <a:buNone/>
               <a:defRPr sz="3600" b="1">
                 <a:solidFill>
                   <a:srgbClr val="171B19"/>
@@ -1725,6 +1801,7 @@
           <a:lstStyle xmlns:a="http://schemas.openxmlformats.org/drawingml/2006/main"/>
           <a:p xmlns:a="http://schemas.openxmlformats.org/drawingml/2006/main">
             <a:pPr>
+              <a:buNone/>
               <a:defRPr sz="2550" b="0">
                 <a:solidFill>
                   <a:srgbClr val="171B19"/>
@@ -1748,6 +1825,7 @@
           </a:p>
           <a:p xmlns:a="http://schemas.openxmlformats.org/drawingml/2006/main">
             <a:pPr>
+              <a:buNone/>
               <a:defRPr sz="2550" b="0">
                 <a:solidFill>
                   <a:srgbClr val="171B19"/>
@@ -1805,6 +1883,7 @@
           <a:lstStyle xmlns:a="http://schemas.openxmlformats.org/drawingml/2006/main"/>
           <a:p xmlns:a="http://schemas.openxmlformats.org/drawingml/2006/main">
             <a:pPr>
+              <a:buNone/>
               <a:defRPr sz="2250" b="1">
                 <a:solidFill>
                   <a:srgbClr val="171B19"/>
@@ -1862,6 +1941,7 @@
           <a:lstStyle xmlns:a="http://schemas.openxmlformats.org/drawingml/2006/main"/>
           <a:p xmlns:a="http://schemas.openxmlformats.org/drawingml/2006/main">
             <a:pPr>
+              <a:buNone/>
               <a:defRPr sz="2250" b="0">
                 <a:solidFill>
                   <a:srgbClr val="171B19"/>
@@ -1885,6 +1965,7 @@
           </a:p>
           <a:p xmlns:a="http://schemas.openxmlformats.org/drawingml/2006/main">
             <a:pPr>
+              <a:buNone/>
               <a:defRPr sz="2250" b="0">
                 <a:solidFill>
                   <a:srgbClr val="171B19"/>
@@ -1908,6 +1989,7 @@
           </a:p>
           <a:p xmlns:a="http://schemas.openxmlformats.org/drawingml/2006/main">
             <a:pPr>
+              <a:buNone/>
               <a:defRPr sz="2250" b="0">
                 <a:solidFill>
                   <a:srgbClr val="171B19"/>
@@ -1994,6 +2076,7 @@
           <a:lstStyle xmlns:a="http://schemas.openxmlformats.org/drawingml/2006/main"/>
           <a:p xmlns:a="http://schemas.openxmlformats.org/drawingml/2006/main">
             <a:pPr>
+              <a:buNone/>
               <a:defRPr sz="3600" b="1">
                 <a:solidFill>
                   <a:srgbClr val="171B19"/>
@@ -2051,6 +2134,7 @@
           <a:lstStyle xmlns:a="http://schemas.openxmlformats.org/drawingml/2006/main"/>
           <a:p xmlns:a="http://schemas.openxmlformats.org/drawingml/2006/main">
             <a:pPr>
+              <a:buNone/>
               <a:defRPr sz="2250" b="0">
                 <a:solidFill>
                   <a:srgbClr val="171B19"/>
@@ -2108,6 +2192,7 @@
           <a:lstStyle xmlns:a="http://schemas.openxmlformats.org/drawingml/2006/main"/>
           <a:p xmlns:a="http://schemas.openxmlformats.org/drawingml/2006/main">
             <a:pPr>
+              <a:buNone/>
               <a:defRPr sz="2250" b="0">
                 <a:solidFill>
                   <a:srgbClr val="171B19"/>
@@ -2165,6 +2250,7 @@
           <a:lstStyle xmlns:a="http://schemas.openxmlformats.org/drawingml/2006/main"/>
           <a:p xmlns:a="http://schemas.openxmlformats.org/drawingml/2006/main">
             <a:pPr>
+              <a:buNone/>
               <a:defRPr sz="2250" b="0">
                 <a:solidFill>
                   <a:srgbClr val="171B19"/>
@@ -2222,6 +2308,7 @@
           <a:lstStyle xmlns:a="http://schemas.openxmlformats.org/drawingml/2006/main"/>
           <a:p xmlns:a="http://schemas.openxmlformats.org/drawingml/2006/main">
             <a:pPr>
+              <a:buNone/>
               <a:defRPr sz="2250" b="0">
                 <a:solidFill>
                   <a:srgbClr val="171B19"/>
@@ -2279,6 +2366,7 @@
           <a:lstStyle xmlns:a="http://schemas.openxmlformats.org/drawingml/2006/main"/>
           <a:p xmlns:a="http://schemas.openxmlformats.org/drawingml/2006/main">
             <a:pPr>
+              <a:buNone/>
               <a:defRPr sz="2250" b="0">
                 <a:solidFill>
                   <a:srgbClr val="171B19"/>
@@ -2365,6 +2453,7 @@
           <a:lstStyle xmlns:a="http://schemas.openxmlformats.org/drawingml/2006/main"/>
           <a:p xmlns:a="http://schemas.openxmlformats.org/drawingml/2006/main">
             <a:pPr>
+              <a:buNone/>
               <a:defRPr sz="3600" b="1">
                 <a:solidFill>
                   <a:srgbClr val="171B19"/>
@@ -2390,14 +2479,14 @@
       </p:sp>
       <p:pic>
         <p:nvPicPr>
-          <p:cNvPr id="6" name=""/>
+          <p:cNvPr id="8" name=""/>
           <p:cNvPicPr>
             <a:picLocks xmlns:a="http://schemas.openxmlformats.org/drawingml/2006/main" noChangeAspect="1"/>
           </p:cNvPicPr>
           <p:nvPr/>
         </p:nvPicPr>
         <p:blipFill>
-          <a:blip xmlns:r="http://schemas.openxmlformats.org/officeDocument/2006/relationships" xmlns:a="http://schemas.openxmlformats.org/drawingml/2006/main" r:embed="Reab725eccec84e65"/>
+          <a:blip xmlns:r="http://schemas.openxmlformats.org/officeDocument/2006/relationships" xmlns:a="http://schemas.openxmlformats.org/drawingml/2006/main" r:embed="R4df4084ceb81436c"/>
           <a:stretch xmlns:a="http://schemas.openxmlformats.org/drawingml/2006/main"/>
         </p:blipFill>
         <p:spPr>
@@ -2444,6 +2533,7 @@
           <a:lstStyle xmlns:a="http://schemas.openxmlformats.org/drawingml/2006/main"/>
           <a:p xmlns:a="http://schemas.openxmlformats.org/drawingml/2006/main">
             <a:pPr>
+              <a:buNone/>
               <a:defRPr sz="2550" b="1">
                 <a:solidFill>
                   <a:srgbClr val="171B19"/>
@@ -2501,6 +2591,7 @@
           <a:lstStyle xmlns:a="http://schemas.openxmlformats.org/drawingml/2006/main"/>
           <a:p xmlns:a="http://schemas.openxmlformats.org/drawingml/2006/main">
             <a:pPr>
+              <a:buNone/>
               <a:defRPr sz="2100" b="0">
                 <a:solidFill>
                   <a:srgbClr val="171B19"/>
@@ -2524,6 +2615,7 @@
           </a:p>
           <a:p xmlns:a="http://schemas.openxmlformats.org/drawingml/2006/main">
             <a:pPr>
+              <a:buNone/>
               <a:defRPr sz="2100" b="0">
                 <a:solidFill>
                   <a:srgbClr val="171B19"/>
@@ -2610,6 +2702,7 @@
           <a:lstStyle xmlns:a="http://schemas.openxmlformats.org/drawingml/2006/main"/>
           <a:p xmlns:a="http://schemas.openxmlformats.org/drawingml/2006/main">
             <a:pPr>
+              <a:buNone/>
               <a:defRPr sz="3600" b="1">
                 <a:solidFill>
                   <a:srgbClr val="171B19"/>
@@ -2667,6 +2760,7 @@
           <a:lstStyle xmlns:a="http://schemas.openxmlformats.org/drawingml/2006/main"/>
           <a:p xmlns:a="http://schemas.openxmlformats.org/drawingml/2006/main">
             <a:pPr>
+              <a:buNone/>
               <a:defRPr sz="2250" b="0">
                 <a:solidFill>
                   <a:srgbClr val="171B19"/>
@@ -2690,6 +2784,7 @@
           </a:p>
           <a:p xmlns:a="http://schemas.openxmlformats.org/drawingml/2006/main">
             <a:pPr>
+              <a:buNone/>
               <a:defRPr sz="2250" b="0">
                 <a:solidFill>
                   <a:srgbClr val="171B19"/>
@@ -2747,6 +2842,7 @@
           <a:lstStyle xmlns:a="http://schemas.openxmlformats.org/drawingml/2006/main"/>
           <a:p xmlns:a="http://schemas.openxmlformats.org/drawingml/2006/main">
             <a:pPr>
+              <a:buNone/>
               <a:defRPr sz="2250" b="0">
                 <a:solidFill>
                   <a:srgbClr val="171B19"/>
@@ -2770,6 +2866,7 @@
           </a:p>
           <a:p xmlns:a="http://schemas.openxmlformats.org/drawingml/2006/main">
             <a:pPr>
+              <a:buNone/>
               <a:defRPr sz="2250" b="0">
                 <a:solidFill>
                   <a:srgbClr val="171B19"/>
@@ -2793,6 +2890,7 @@
           </a:p>
           <a:p xmlns:a="http://schemas.openxmlformats.org/drawingml/2006/main">
             <a:pPr>
+              <a:buNone/>
               <a:defRPr sz="2250" b="0">
                 <a:solidFill>
                   <a:srgbClr val="171B19"/>
@@ -2879,6 +2977,7 @@
           <a:lstStyle xmlns:a="http://schemas.openxmlformats.org/drawingml/2006/main"/>
           <a:p xmlns:a="http://schemas.openxmlformats.org/drawingml/2006/main">
             <a:pPr>
+              <a:buNone/>
               <a:defRPr sz="3600" b="1">
                 <a:solidFill>
                   <a:srgbClr val="171B19"/>
@@ -2936,6 +3035,7 @@
           <a:lstStyle xmlns:a="http://schemas.openxmlformats.org/drawingml/2006/main"/>
           <a:p xmlns:a="http://schemas.openxmlformats.org/drawingml/2006/main">
             <a:pPr>
+              <a:buNone/>
               <a:defRPr sz="2400" b="1">
                 <a:solidFill>
                   <a:srgbClr val="171B19"/>
@@ -2993,6 +3093,7 @@
           <a:lstStyle xmlns:a="http://schemas.openxmlformats.org/drawingml/2006/main"/>
           <a:p xmlns:a="http://schemas.openxmlformats.org/drawingml/2006/main">
             <a:pPr>
+              <a:buNone/>
               <a:defRPr sz="2175" b="0">
                 <a:solidFill>
                   <a:srgbClr val="171B19"/>
@@ -3016,6 +3117,7 @@
           </a:p>
           <a:p xmlns:a="http://schemas.openxmlformats.org/drawingml/2006/main">
             <a:pPr>
+              <a:buNone/>
               <a:defRPr sz="2175" b="0">
                 <a:solidFill>
                   <a:srgbClr val="171B19"/>
@@ -3073,6 +3175,7 @@
           <a:lstStyle xmlns:a="http://schemas.openxmlformats.org/drawingml/2006/main"/>
           <a:p xmlns:a="http://schemas.openxmlformats.org/drawingml/2006/main">
             <a:pPr>
+              <a:buNone/>
               <a:defRPr sz="2175" b="0">
                 <a:solidFill>
                   <a:srgbClr val="171B19"/>
@@ -3096,6 +3199,7 @@
           </a:p>
           <a:p xmlns:a="http://schemas.openxmlformats.org/drawingml/2006/main">
             <a:pPr>
+              <a:buNone/>
               <a:defRPr sz="2175" b="0">
                 <a:solidFill>
                   <a:srgbClr val="171B19"/>
@@ -3153,6 +3257,7 @@
           <a:lstStyle xmlns:a="http://schemas.openxmlformats.org/drawingml/2006/main"/>
           <a:p xmlns:a="http://schemas.openxmlformats.org/drawingml/2006/main">
             <a:pPr>
+              <a:buNone/>
               <a:defRPr sz="1800" b="0">
                 <a:solidFill>
                   <a:srgbClr val="171B19"/>
@@ -3180,6 +3285,263 @@
     <p:extLst>
       <p:ext uri="{BB962C8B-B14F-4D97-AF65-F5344CB8AC3E}">
         <p14:creationId xmlns:p14="http://schemas.microsoft.com/office/powerpoint/2010/main" val="755052807"/>
+      </p:ext>
+    </p:extLst>
+  </p:cSld>
+</p:sld>
+</file>
+
+<file path=ppt/slides/slide7.xml><?xml version="1.0" encoding="utf-8"?>
+<p:sld xmlns:p="http://schemas.openxmlformats.org/presentationml/2006/main">
+  <p:cSld>
+    <p:bg>
+      <p:bgPr>
+        <a:solidFill xmlns:a="http://schemas.openxmlformats.org/drawingml/2006/main">
+          <a:srgbClr val="FFFFFF"/>
+        </a:solidFill>
+      </p:bgPr>
+    </p:bg>
+    <p:spTree>
+      <p:nvGrpSpPr>
+        <p:cNvPr id="1" name=""/>
+        <p:cNvGrpSpPr/>
+        <p:nvPr/>
+      </p:nvGrpSpPr>
+      <p:grpSpPr>
+        <a:xfrm xmlns:a="http://schemas.openxmlformats.org/drawingml/2006/main"/>
+      </p:grpSpPr>
+      <p:sp>
+        <p:nvSpPr>
+          <p:cNvPr id="5" name="">
+            <a:extLst xmlns:a="http://schemas.openxmlformats.org/drawingml/2006/main">
+              <a:ext uri="{FF2B5EF4-FFF2-40B4-BE49-F238E27FC236}">
+                <a16:creationId xmlns:a16="http://schemas.microsoft.com/office/drawing/2014/main" id="{E2474243-B8BC-4151-8363-0B90D333B078}"/>
+              </a:ext>
+            </a:extLst>
+          </p:cNvPr>
+          <p:cNvSpPr>
+            <a:spLocks xmlns:a="http://schemas.openxmlformats.org/drawingml/2006/main" noGrp="1"/>
+          </p:cNvSpPr>
+          <p:nvPr/>
+        </p:nvSpPr>
+        <p:spPr>
+          <a:xfrm xmlns:a="http://schemas.openxmlformats.org/drawingml/2006/main">
+            <a:off x="609600" y="419100"/>
+            <a:ext cx="10953750" cy="876300"/>
+          </a:xfrm>
+          <a:prstGeom xmlns:a="http://schemas.openxmlformats.org/drawingml/2006/main" prst="rect">
+            <a:avLst/>
+          </a:prstGeom>
+          <a:noFill xmlns:a="http://schemas.openxmlformats.org/drawingml/2006/main"/>
+          <a:ln xmlns:a="http://schemas.openxmlformats.org/drawingml/2006/main" w="0">
+            <a:noFill/>
+          </a:ln>
+        </p:spPr>
+        <p:txBody>
+          <a:bodyPr xmlns:a="http://schemas.openxmlformats.org/drawingml/2006/main">
+            <a:noAutofit/>
+          </a:bodyPr>
+          <a:lstStyle xmlns:a="http://schemas.openxmlformats.org/drawingml/2006/main"/>
+          <a:p xmlns:a="http://schemas.openxmlformats.org/drawingml/2006/main">
+            <a:pPr>
+              <a:defRPr sz="3600" b="1">
+                <a:solidFill>
+                  <a:srgbClr val="111111"/>
+                </a:solidFill>
+                <a:latin typeface="Helvetica Neue"/>
+                <a:ea typeface="Helvetica Neue"/>
+                <a:cs typeface="Helvetica Neue"/>
+              </a:defRPr>
+            </a:pPr>
+            <a:r>
+              <a:rPr sz="3600" b="1">
+                <a:solidFill>
+                  <a:srgbClr val="111111"/>
+                </a:solidFill>
+                <a:latin typeface="Helvetica Neue"/>
+                <a:ea typeface="Helvetica Neue"/>
+                <a:cs typeface="Helvetica Neue"/>
+              </a:rPr>
+              <a:t>Future scope</a:t>
+            </a:r>
+          </a:p>
+        </p:txBody>
+      </p:sp>
+      <p:sp>
+        <p:nvSpPr>
+          <p:cNvPr id="2" name="">
+            <a:extLst xmlns:a="http://schemas.openxmlformats.org/drawingml/2006/main">
+              <a:ext uri="{FF2B5EF4-FFF2-40B4-BE49-F238E27FC236}">
+                <a16:creationId xmlns:a16="http://schemas.microsoft.com/office/drawing/2014/main" id="{2A60227A-94A0-4BE0-AF11-3344CC01E71B}"/>
+              </a:ext>
+            </a:extLst>
+          </p:cNvPr>
+          <p:cNvSpPr>
+            <a:spLocks xmlns:a="http://schemas.openxmlformats.org/drawingml/2006/main" noGrp="1"/>
+          </p:cNvSpPr>
+          <p:nvPr/>
+        </p:nvSpPr>
+        <p:spPr>
+          <a:xfrm xmlns:a="http://schemas.openxmlformats.org/drawingml/2006/main">
+            <a:off x="609600" y="1666875"/>
+            <a:ext cx="10953750" cy="762000"/>
+          </a:xfrm>
+          <a:prstGeom xmlns:a="http://schemas.openxmlformats.org/drawingml/2006/main" prst="rect">
+            <a:avLst/>
+          </a:prstGeom>
+          <a:noFill xmlns:a="http://schemas.openxmlformats.org/drawingml/2006/main"/>
+          <a:ln xmlns:a="http://schemas.openxmlformats.org/drawingml/2006/main" w="0">
+            <a:noFill/>
+          </a:ln>
+        </p:spPr>
+        <p:txBody>
+          <a:bodyPr xmlns:a="http://schemas.openxmlformats.org/drawingml/2006/main">
+            <a:noAutofit/>
+          </a:bodyPr>
+          <a:lstStyle xmlns:a="http://schemas.openxmlformats.org/drawingml/2006/main"/>
+          <a:p xmlns:a="http://schemas.openxmlformats.org/drawingml/2006/main">
+            <a:pPr>
+              <a:defRPr sz="2400" b="1">
+                <a:solidFill>
+                  <a:srgbClr val="111111"/>
+                </a:solidFill>
+                <a:latin typeface="Helvetica Neue"/>
+                <a:ea typeface="Helvetica Neue"/>
+                <a:cs typeface="Helvetica Neue"/>
+              </a:defRPr>
+            </a:pPr>
+            <a:r>
+              <a:rPr sz="2400" b="1">
+                <a:solidFill>
+                  <a:srgbClr val="111111"/>
+                </a:solidFill>
+                <a:latin typeface="Helvetica Neue"/>
+                <a:ea typeface="Helvetica Neue"/>
+                <a:cs typeface="Helvetica Neue"/>
+              </a:rPr>
+              <a:t>Independent-provider comparison</a:t>
+            </a:r>
+          </a:p>
+        </p:txBody>
+      </p:sp>
+      <p:sp>
+        <p:nvSpPr>
+          <p:cNvPr id="3" name="">
+            <a:extLst xmlns:a="http://schemas.openxmlformats.org/drawingml/2006/main">
+              <a:ext uri="{FF2B5EF4-FFF2-40B4-BE49-F238E27FC236}">
+                <a16:creationId xmlns:a16="http://schemas.microsoft.com/office/drawing/2014/main" id="{CADCEF9D-6590-4214-9A49-25D5BF76C1AC}"/>
+              </a:ext>
+            </a:extLst>
+          </p:cNvPr>
+          <p:cNvSpPr>
+            <a:spLocks xmlns:a="http://schemas.openxmlformats.org/drawingml/2006/main" noGrp="1"/>
+          </p:cNvSpPr>
+          <p:nvPr/>
+        </p:nvSpPr>
+        <p:spPr>
+          <a:xfrm xmlns:a="http://schemas.openxmlformats.org/drawingml/2006/main">
+            <a:off x="609600" y="2762250"/>
+            <a:ext cx="10953750" cy="762000"/>
+          </a:xfrm>
+          <a:prstGeom xmlns:a="http://schemas.openxmlformats.org/drawingml/2006/main" prst="rect">
+            <a:avLst/>
+          </a:prstGeom>
+          <a:noFill xmlns:a="http://schemas.openxmlformats.org/drawingml/2006/main"/>
+          <a:ln xmlns:a="http://schemas.openxmlformats.org/drawingml/2006/main" w="0">
+            <a:noFill/>
+          </a:ln>
+        </p:spPr>
+        <p:txBody>
+          <a:bodyPr xmlns:a="http://schemas.openxmlformats.org/drawingml/2006/main">
+            <a:noAutofit/>
+          </a:bodyPr>
+          <a:lstStyle xmlns:a="http://schemas.openxmlformats.org/drawingml/2006/main"/>
+          <a:p xmlns:a="http://schemas.openxmlformats.org/drawingml/2006/main">
+            <a:pPr>
+              <a:defRPr sz="2400" b="1">
+                <a:solidFill>
+                  <a:srgbClr val="111111"/>
+                </a:solidFill>
+                <a:latin typeface="Helvetica Neue"/>
+                <a:ea typeface="Helvetica Neue"/>
+                <a:cs typeface="Helvetica Neue"/>
+              </a:defRPr>
+            </a:pPr>
+            <a:r>
+              <a:rPr sz="2400" b="1">
+                <a:solidFill>
+                  <a:srgbClr val="111111"/>
+                </a:solidFill>
+                <a:latin typeface="Helvetica Neue"/>
+                <a:ea typeface="Helvetica Neue"/>
+                <a:cs typeface="Helvetica Neue"/>
+              </a:rPr>
+              <a:t>Explicit invoice identifiers</a:t>
+            </a:r>
+          </a:p>
+        </p:txBody>
+      </p:sp>
+      <p:sp>
+        <p:nvSpPr>
+          <p:cNvPr id="4" name="">
+            <a:extLst xmlns:a="http://schemas.openxmlformats.org/drawingml/2006/main">
+              <a:ext uri="{FF2B5EF4-FFF2-40B4-BE49-F238E27FC236}">
+                <a16:creationId xmlns:a16="http://schemas.microsoft.com/office/drawing/2014/main" id="{482C6F70-E79E-452F-8E49-01204460FEFD}"/>
+              </a:ext>
+            </a:extLst>
+          </p:cNvPr>
+          <p:cNvSpPr>
+            <a:spLocks xmlns:a="http://schemas.openxmlformats.org/drawingml/2006/main" noGrp="1"/>
+          </p:cNvSpPr>
+          <p:nvPr/>
+        </p:nvSpPr>
+        <p:spPr>
+          <a:xfrm xmlns:a="http://schemas.openxmlformats.org/drawingml/2006/main">
+            <a:off x="609600" y="4238625"/>
+            <a:ext cx="10953750" cy="1047750"/>
+          </a:xfrm>
+          <a:prstGeom xmlns:a="http://schemas.openxmlformats.org/drawingml/2006/main" prst="rect">
+            <a:avLst/>
+          </a:prstGeom>
+          <a:noFill xmlns:a="http://schemas.openxmlformats.org/drawingml/2006/main"/>
+          <a:ln xmlns:a="http://schemas.openxmlformats.org/drawingml/2006/main" w="0">
+            <a:noFill/>
+          </a:ln>
+        </p:spPr>
+        <p:txBody>
+          <a:bodyPr xmlns:a="http://schemas.openxmlformats.org/drawingml/2006/main">
+            <a:noAutofit/>
+          </a:bodyPr>
+          <a:lstStyle xmlns:a="http://schemas.openxmlformats.org/drawingml/2006/main"/>
+          <a:p xmlns:a="http://schemas.openxmlformats.org/drawingml/2006/main">
+            <a:pPr>
+              <a:defRPr sz="2100" b="0">
+                <a:solidFill>
+                  <a:srgbClr val="111111"/>
+                </a:solidFill>
+                <a:latin typeface="Helvetica Neue"/>
+                <a:ea typeface="Helvetica Neue"/>
+                <a:cs typeface="Helvetica Neue"/>
+              </a:defRPr>
+            </a:pPr>
+            <a:r>
+              <a:rPr sz="2100" b="0">
+                <a:solidFill>
+                  <a:srgbClr val="111111"/>
+                </a:solidFill>
+                <a:latin typeface="Helvetica Neue"/>
+                <a:ea typeface="Helvetica Neue"/>
+                <a:cs typeface="Helvetica Neue"/>
+              </a:rPr>
+              <a:t>These are not implemented in this prototype.</a:t>
+            </a:r>
+          </a:p>
+        </p:txBody>
+      </p:sp>
+    </p:spTree>
+    <p:extLst>
+      <p:ext uri="{BB962C8B-B14F-4D97-AF65-F5344CB8AC3E}">
+        <p14:creationId xmlns:p14="http://schemas.microsoft.com/office/powerpoint/2010/main" val="375504189"/>
       </p:ext>
     </p:extLst>
   </p:cSld>

</xml_diff>